<commit_message>
Improve portfolio design and evidence presentations
</commit_message>
<xml_diff>
--- a/public/presentations/manufacturing-rag-assistant/manufacturing-rag-assistant-evidence-deck.pptx
+++ b/public/presentations/manufacturing-rag-assistant/manufacturing-rag-assistant-evidence-deck.pptx
@@ -2,22 +2,22 @@
 <file path=ppt/presentation.xml><?xml version="1.0" encoding="utf-8"?>
 <p:presentation xmlns:p="http://schemas.openxmlformats.org/presentationml/2006/main">
   <p:sldMasterIdLst>
-    <p:sldMasterId xmlns:r="http://schemas.openxmlformats.org/officeDocument/2006/relationships" id="2147483648" r:id="Rc77e6c7de4b84fe4"/>
+    <p:sldMasterId xmlns:r="http://schemas.openxmlformats.org/officeDocument/2006/relationships" id="2147483648" r:id="R1d30043f4d19459a"/>
   </p:sldMasterIdLst>
   <p:notesMasterIdLst>
-    <p:notesMasterId xmlns:r="http://schemas.openxmlformats.org/officeDocument/2006/relationships" r:id="Ra8a91c46094b40dd"/>
+    <p:notesMasterId xmlns:r="http://schemas.openxmlformats.org/officeDocument/2006/relationships" r:id="Rbd8f2445f75241c4"/>
   </p:notesMasterIdLst>
   <p:sldIdLst>
-    <p:sldId xmlns:r="http://schemas.openxmlformats.org/officeDocument/2006/relationships" id="256" r:id="R8c9d389b1b864c43"/>
-    <p:sldId xmlns:r="http://schemas.openxmlformats.org/officeDocument/2006/relationships" id="257" r:id="Rd79d3907bbd04e65"/>
-    <p:sldId xmlns:r="http://schemas.openxmlformats.org/officeDocument/2006/relationships" id="258" r:id="Re0c63c1ea40142c3"/>
-    <p:sldId xmlns:r="http://schemas.openxmlformats.org/officeDocument/2006/relationships" id="259" r:id="Rfacd1b0f2a2c406e"/>
-    <p:sldId xmlns:r="http://schemas.openxmlformats.org/officeDocument/2006/relationships" id="260" r:id="R34e708d2b1314542"/>
-    <p:sldId xmlns:r="http://schemas.openxmlformats.org/officeDocument/2006/relationships" id="261" r:id="R57a7557680e946f6"/>
-    <p:sldId xmlns:r="http://schemas.openxmlformats.org/officeDocument/2006/relationships" id="262" r:id="Red9c8c1c7014436f"/>
-    <p:sldId xmlns:r="http://schemas.openxmlformats.org/officeDocument/2006/relationships" id="263" r:id="R4fd0611bbdf34323"/>
-    <p:sldId xmlns:r="http://schemas.openxmlformats.org/officeDocument/2006/relationships" id="264" r:id="R3841cc2c17ca4d59"/>
-    <p:sldId xmlns:r="http://schemas.openxmlformats.org/officeDocument/2006/relationships" id="265" r:id="Re124f563041c4614"/>
+    <p:sldId xmlns:r="http://schemas.openxmlformats.org/officeDocument/2006/relationships" id="256" r:id="Rb2d68781260a4b6c"/>
+    <p:sldId xmlns:r="http://schemas.openxmlformats.org/officeDocument/2006/relationships" id="257" r:id="R546fc4b00c1f4292"/>
+    <p:sldId xmlns:r="http://schemas.openxmlformats.org/officeDocument/2006/relationships" id="258" r:id="R880ed2f504c64001"/>
+    <p:sldId xmlns:r="http://schemas.openxmlformats.org/officeDocument/2006/relationships" id="259" r:id="R34ad5be16056420b"/>
+    <p:sldId xmlns:r="http://schemas.openxmlformats.org/officeDocument/2006/relationships" id="260" r:id="R3aca5aa9689547c0"/>
+    <p:sldId xmlns:r="http://schemas.openxmlformats.org/officeDocument/2006/relationships" id="261" r:id="Re801188e1a094e68"/>
+    <p:sldId xmlns:r="http://schemas.openxmlformats.org/officeDocument/2006/relationships" id="262" r:id="R8743fddcc5fa4a11"/>
+    <p:sldId xmlns:r="http://schemas.openxmlformats.org/officeDocument/2006/relationships" id="263" r:id="R3563563f80fc49e9"/>
+    <p:sldId xmlns:r="http://schemas.openxmlformats.org/officeDocument/2006/relationships" id="264" r:id="R6a99affade3146ee"/>
+    <p:sldId xmlns:r="http://schemas.openxmlformats.org/officeDocument/2006/relationships" id="265" r:id="R562e3372a3194ab2"/>
   </p:sldIdLst>
   <p:sldSz cx="12192000" cy="6858000"/>
   <p:notesSz cx="6858000" cy="9144000"/>
@@ -1329,7 +1329,7 @@
   </p:cSld>
   <p:clrMap bg1="lt1" tx1="dk1" bg2="lt2" tx2="dk2" accent1="accent1" accent2="accent2" accent3="accent3" accent4="accent4" accent5="accent5" accent6="accent6" hlink="hlink" folHlink="folHlink"/>
   <p:sldLayoutIdLst>
-    <p:sldLayoutId xmlns:r="http://schemas.openxmlformats.org/officeDocument/2006/relationships" id="2147483649" r:id="Rd202dac586224023"/>
+    <p:sldLayoutId xmlns:r="http://schemas.openxmlformats.org/officeDocument/2006/relationships" id="2147483649" r:id="R112a2783c8e34c88"/>
   </p:sldLayoutIdLst>
   <p:txStyles>
     <p:titleStyle>
@@ -2225,7 +2225,7 @@
           <p:nvPr/>
         </p:nvPicPr>
         <p:blipFill>
-          <a:blip xmlns:r="http://schemas.openxmlformats.org/officeDocument/2006/relationships" xmlns:a="http://schemas.openxmlformats.org/drawingml/2006/main" r:embed="Rd2dc68c5b44b4754"/>
+          <a:blip xmlns:r="http://schemas.openxmlformats.org/officeDocument/2006/relationships" xmlns:a="http://schemas.openxmlformats.org/drawingml/2006/main" r:embed="R3fbcb17036ca4ea5"/>
           <a:stretch xmlns:a="http://schemas.openxmlformats.org/drawingml/2006/main"/>
         </p:blipFill>
         <p:spPr>
@@ -3778,7 +3778,7 @@
       </p:sp>
       <p:cxnSp>
         <p:nvCxnSpPr>
-          <p:cNvPr id="99" name=""/>
+          <p:cNvPr id="123" name=""/>
           <p:cNvCxnSpPr>
             <a:stCxn xmlns:a="http://schemas.openxmlformats.org/drawingml/2006/main" id="4" idx="3"/>
             <a:endCxn xmlns:a="http://schemas.openxmlformats.org/drawingml/2006/main" id="5" idx="1"/>
@@ -3804,7 +3804,7 @@
       </p:cxnSp>
       <p:cxnSp>
         <p:nvCxnSpPr>
-          <p:cNvPr id="100" name=""/>
+          <p:cNvPr id="124" name=""/>
           <p:cNvCxnSpPr>
             <a:stCxn xmlns:a="http://schemas.openxmlformats.org/drawingml/2006/main" id="5" idx="3"/>
             <a:endCxn xmlns:a="http://schemas.openxmlformats.org/drawingml/2006/main" id="6" idx="1"/>
@@ -3830,7 +3830,7 @@
       </p:cxnSp>
       <p:cxnSp>
         <p:nvCxnSpPr>
-          <p:cNvPr id="101" name=""/>
+          <p:cNvPr id="125" name=""/>
           <p:cNvCxnSpPr>
             <a:stCxn xmlns:a="http://schemas.openxmlformats.org/drawingml/2006/main" id="6" idx="3"/>
             <a:endCxn xmlns:a="http://schemas.openxmlformats.org/drawingml/2006/main" id="7" idx="1"/>
@@ -3856,7 +3856,7 @@
       </p:cxnSp>
       <p:cxnSp>
         <p:nvCxnSpPr>
-          <p:cNvPr id="102" name=""/>
+          <p:cNvPr id="126" name=""/>
           <p:cNvCxnSpPr>
             <a:stCxn xmlns:a="http://schemas.openxmlformats.org/drawingml/2006/main" id="7" idx="3"/>
             <a:endCxn xmlns:a="http://schemas.openxmlformats.org/drawingml/2006/main" id="8" idx="1"/>
@@ -5145,7 +5145,7 @@
                   <a:srgbClr val="5E7390"/>
                 </a:solidFill>
               </a:rPr>
-              <a:t>RETRIEVAL</a:t>
+              <a:t>CURRENT PROFILE</a:t>
             </a:r>
           </a:p>
         </p:txBody>
@@ -5231,7 +5231,7 @@
                   <a:srgbClr val="10233F"/>
                 </a:solidFill>
               </a:rPr>
-              <a:t>Correct refusal*</a:t>
+              <a:t>Correct refusal</a:t>
             </a:r>
           </a:p>
         </p:txBody>
@@ -5333,7 +5333,7 @@
                   <a:srgbClr val="5E7390"/>
                 </a:solidFill>
               </a:rPr>
-              <a:t>GUARDRAIL</a:t>
+              <a:t>HISTORICAL</a:t>
             </a:r>
           </a:p>
         </p:txBody>
@@ -5419,7 +5419,7 @@
                   <a:srgbClr val="10233F"/>
                 </a:solidFill>
               </a:rPr>
-              <a:t>Faithfulness*</a:t>
+              <a:t>Faithfulness</a:t>
             </a:r>
           </a:p>
         </p:txBody>
@@ -5521,7 +5521,7 @@
                   <a:srgbClr val="5E7390"/>
                 </a:solidFill>
               </a:rPr>
-              <a:t>29 / 30</a:t>
+              <a:t>HIST. · 29 / 30</a:t>
             </a:r>
           </a:p>
         </p:txBody>
@@ -5607,7 +5607,7 @@
                   <a:srgbClr val="10233F"/>
                 </a:solidFill>
               </a:rPr>
-              <a:t>Citation accuracy*</a:t>
+              <a:t>Citation accuracy</a:t>
             </a:r>
           </a:p>
         </p:txBody>
@@ -5709,7 +5709,7 @@
                   <a:srgbClr val="5E7390"/>
                 </a:solidFill>
               </a:rPr>
-              <a:t>BELOW TARGET</a:t>
+              <a:t>HIST. · BELOW TARGET</a:t>
             </a:r>
           </a:p>
         </p:txBody>
@@ -5795,7 +5795,7 @@
                   <a:srgbClr val="FFFFFF"/>
                 </a:solidFill>
               </a:rPr>
-              <a:t>Current retrieval: Recall@5 0.887 (ES 0.844, n=32; EN 0.917, n=48). *Generation metrics are historical raw-v1 / eval_set v1.0.0 measurements.</a:t>
+              <a:t>Current retrieval: Recall@5 0.887 (ES 0.844, n=32; EN 0.917, n=48). Generation cards preserve historical raw-v1 / eval_set v1.0.0 measurements.</a:t>
             </a:r>
           </a:p>
         </p:txBody>
@@ -6110,7 +6110,7 @@
           <p:nvPr/>
         </p:nvPicPr>
         <p:blipFill>
-          <a:blip xmlns:r="http://schemas.openxmlformats.org/officeDocument/2006/relationships" xmlns:a="http://schemas.openxmlformats.org/drawingml/2006/main" r:embed="Re1c90fb5cd2f4c7e"/>
+          <a:blip xmlns:r="http://schemas.openxmlformats.org/officeDocument/2006/relationships" xmlns:a="http://schemas.openxmlformats.org/drawingml/2006/main" r:embed="R91f65dacc62d453d"/>
           <a:stretch xmlns:a="http://schemas.openxmlformats.org/drawingml/2006/main"/>
         </p:blipFill>
         <p:spPr>
@@ -7920,7 +7920,7 @@
           <p:nvPr/>
         </p:nvPicPr>
         <p:blipFill>
-          <a:blip xmlns:r="http://schemas.openxmlformats.org/officeDocument/2006/relationships" xmlns:a="http://schemas.openxmlformats.org/drawingml/2006/main" r:embed="R8c24d934a43a4124"/>
+          <a:blip xmlns:r="http://schemas.openxmlformats.org/officeDocument/2006/relationships" xmlns:a="http://schemas.openxmlformats.org/drawingml/2006/main" r:embed="Rfb2ea68863184d36"/>
           <a:stretch xmlns:a="http://schemas.openxmlformats.org/drawingml/2006/main"/>
         </p:blipFill>
         <p:spPr>
@@ -8376,7 +8376,7 @@
       </p:sp>
       <p:cxnSp>
         <p:nvCxnSpPr>
-          <p:cNvPr id="99" name=""/>
+          <p:cNvPr id="123" name=""/>
           <p:cNvCxnSpPr>
             <a:stCxn xmlns:a="http://schemas.openxmlformats.org/drawingml/2006/main" id="4" idx="3"/>
             <a:endCxn xmlns:a="http://schemas.openxmlformats.org/drawingml/2006/main" id="5" idx="1"/>
@@ -8402,7 +8402,7 @@
       </p:cxnSp>
       <p:cxnSp>
         <p:nvCxnSpPr>
-          <p:cNvPr id="100" name=""/>
+          <p:cNvPr id="124" name=""/>
           <p:cNvCxnSpPr>
             <a:stCxn xmlns:a="http://schemas.openxmlformats.org/drawingml/2006/main" id="5" idx="3"/>
             <a:endCxn xmlns:a="http://schemas.openxmlformats.org/drawingml/2006/main" id="6" idx="1"/>
@@ -8428,7 +8428,7 @@
       </p:cxnSp>
       <p:cxnSp>
         <p:nvCxnSpPr>
-          <p:cNvPr id="101" name=""/>
+          <p:cNvPr id="125" name=""/>
           <p:cNvCxnSpPr>
             <a:stCxn xmlns:a="http://schemas.openxmlformats.org/drawingml/2006/main" id="6" idx="3"/>
             <a:endCxn xmlns:a="http://schemas.openxmlformats.org/drawingml/2006/main" id="7" idx="1"/>
@@ -8454,7 +8454,7 @@
       </p:cxnSp>
       <p:cxnSp>
         <p:nvCxnSpPr>
-          <p:cNvPr id="102" name=""/>
+          <p:cNvPr id="126" name=""/>
           <p:cNvCxnSpPr>
             <a:stCxn xmlns:a="http://schemas.openxmlformats.org/drawingml/2006/main" id="7" idx="3"/>
             <a:endCxn xmlns:a="http://schemas.openxmlformats.org/drawingml/2006/main" id="8" idx="1"/>
@@ -9743,7 +9743,7 @@
                   <a:srgbClr val="5E7390"/>
                 </a:solidFill>
               </a:rPr>
-              <a:t>RECUPERACIÓN</a:t>
+              <a:t>PERFIL ACTUAL</a:t>
             </a:r>
           </a:p>
         </p:txBody>
@@ -9829,7 +9829,7 @@
                   <a:srgbClr val="10233F"/>
                 </a:solidFill>
               </a:rPr>
-              <a:t>Rechazo correcto*</a:t>
+              <a:t>Rechazo correcto</a:t>
             </a:r>
           </a:p>
         </p:txBody>
@@ -9931,7 +9931,7 @@
                   <a:srgbClr val="5E7390"/>
                 </a:solidFill>
               </a:rPr>
-              <a:t>CONTROL</a:t>
+              <a:t>HISTÓRICO</a:t>
             </a:r>
           </a:p>
         </p:txBody>
@@ -10017,7 +10017,7 @@
                   <a:srgbClr val="10233F"/>
                 </a:solidFill>
               </a:rPr>
-              <a:t>Fidelidad*</a:t>
+              <a:t>Fidelidad</a:t>
             </a:r>
           </a:p>
         </p:txBody>
@@ -10119,7 +10119,7 @@
                   <a:srgbClr val="5E7390"/>
                 </a:solidFill>
               </a:rPr>
-              <a:t>29 / 30</a:t>
+              <a:t>HIST. · 29 / 30</a:t>
             </a:r>
           </a:p>
         </p:txBody>
@@ -10205,7 +10205,7 @@
                   <a:srgbClr val="10233F"/>
                 </a:solidFill>
               </a:rPr>
-              <a:t>Precisión de citas*</a:t>
+              <a:t>Precisión de citas</a:t>
             </a:r>
           </a:p>
         </p:txBody>
@@ -10307,7 +10307,7 @@
                   <a:srgbClr val="5E7390"/>
                 </a:solidFill>
               </a:rPr>
-              <a:t>BAJO LA META</a:t>
+              <a:t>HIST. · BAJO META</a:t>
             </a:r>
           </a:p>
         </p:txBody>
@@ -10393,7 +10393,7 @@
                   <a:srgbClr val="FFFFFF"/>
                 </a:solidFill>
               </a:rPr>
-              <a:t>Recuperación actual: Recall@5 0.887 (ES 0.844, n=32; EN 0.917, n=48). *Generación conserva mediciones históricas de raw-v1 / eval_set v1.0.0.</a:t>
+              <a:t>Recuperación actual: Recall@5 0.887 (ES 0.844, n=32; EN 0.917, n=48). Las tarjetas de generación conservan mediciones históricas de raw-v1 / eval_set v1.0.0.</a:t>
             </a:r>
           </a:p>
         </p:txBody>
@@ -10708,7 +10708,7 @@
           <p:nvPr/>
         </p:nvPicPr>
         <p:blipFill>
-          <a:blip xmlns:r="http://schemas.openxmlformats.org/officeDocument/2006/relationships" xmlns:a="http://schemas.openxmlformats.org/drawingml/2006/main" r:embed="R489c50bd2a3b4f1e"/>
+          <a:blip xmlns:r="http://schemas.openxmlformats.org/officeDocument/2006/relationships" xmlns:a="http://schemas.openxmlformats.org/drawingml/2006/main" r:embed="R9fb351e166784727"/>
           <a:stretch xmlns:a="http://schemas.openxmlformats.org/drawingml/2006/main"/>
         </p:blipFill>
         <p:spPr>
@@ -10818,7 +10818,7 @@
                   <a:srgbClr val="FFFFFF"/>
                 </a:solidFill>
               </a:rPr>
-              <a:t>La respuesta ocupa una frase. La fuente normativa permanece legible junto a ella.</a:t>
+              <a:t>La respuesta ocupa una frase. La fuente técnica permanece legible junto a ella.</a:t>
             </a:r>
           </a:p>
         </p:txBody>

</xml_diff>